<commit_message>
Recount CROSS projectors per internal HW guide
Apply the in-house HW guide (16:10, 15% blending, 250 lx for kids,
floor-projection space height table): wall 1 projector covering the
full 4,500 wall incl. score/timer; floor 2/3/4 projectors depending on
space height (>=4.8 / 4.2-4.8 / 3.8-4.2 m). Update the HTML brief and
the editable plan/section slides.

Co-Authored-By: Claude Opus 5.5 <noreply@anthropic.com>
Claude-Session: https://claude.ai/code/session_011BBjM7b8Q7Xhvjdp6vDPPC
</commit_message>
<xml_diff>
--- a/mission-zone/CROSS_배치평면_단면.pptx
+++ b/mission-zone/CROSS_배치평면_단면.pptx
@@ -2403,13 +2403,13 @@
       </p:sp>
       <p:sp>
         <p:nvSpPr>
-          <p:cNvPr id="59" name="UST_projector_58"/>
-          <p:cNvSpPr/>
-          <p:nvPr/>
-        </p:nvSpPr>
-        <p:spPr>
-          <a:xfrm>
-            <a:off x="2087445" y="1492794"/>
+          <p:cNvPr id="59" name="wall_projector_58"/>
+          <p:cNvSpPr/>
+          <p:nvPr/>
+        </p:nvSpPr>
+        <p:spPr>
+          <a:xfrm>
+            <a:off x="2903873" y="1492794"/>
             <a:ext cx="292608" cy="109728"/>
           </a:xfrm>
           <a:prstGeom prst="roundRect">
@@ -2425,14 +2425,14 @@
       </p:sp>
       <p:sp>
         <p:nvSpPr>
-          <p:cNvPr id="60" name="label_UST_59"/>
+          <p:cNvPr id="60" name="label_wall_projector_59"/>
           <p:cNvSpPr txBox="1"/>
           <p:nvPr/>
         </p:nvSpPr>
         <p:spPr>
           <a:xfrm>
-            <a:off x="2416629" y="1474506"/>
-            <a:ext cx="365760" cy="146304"/>
+            <a:off x="3233057" y="1474506"/>
+            <a:ext cx="640080" cy="146304"/>
           </a:xfrm>
           <a:prstGeom prst="rect">
             <a:avLst/>
@@ -2456,7 +2456,7 @@
                 <a:ea typeface="LINE Seed Sans KR" pitchFamily="34" charset="-122"/>
                 <a:cs typeface="LINE Seed Sans KR" pitchFamily="34" charset="-120"/>
               </a:rPr>
-              <a:t>UST</a:t>
+              <a:t>벽 PJ ×1</a:t>
             </a:r>
             <a:endParaRPr lang="en-US" sz="800" dirty="0"/>
           </a:p>
@@ -2464,13 +2464,13 @@
       </p:sp>
       <p:sp>
         <p:nvSpPr>
-          <p:cNvPr id="61" name="UST_projector_60"/>
-          <p:cNvSpPr/>
-          <p:nvPr/>
-        </p:nvSpPr>
-        <p:spPr>
-          <a:xfrm>
-            <a:off x="3720302" y="1492794"/>
+          <p:cNvPr id="61" name="floor_projector_60"/>
+          <p:cNvSpPr/>
+          <p:nvPr/>
+        </p:nvSpPr>
+        <p:spPr>
+          <a:xfrm>
+            <a:off x="2903873" y="2599073"/>
             <a:ext cx="292608" cy="109728"/>
           </a:xfrm>
           <a:prstGeom prst="roundRect">
@@ -2486,68 +2486,7 @@
       </p:sp>
       <p:sp>
         <p:nvSpPr>
-          <p:cNvPr id="62" name="label_UST_61"/>
-          <p:cNvSpPr txBox="1"/>
-          <p:nvPr/>
-        </p:nvSpPr>
-        <p:spPr>
-          <a:xfrm>
-            <a:off x="4049486" y="1474506"/>
-            <a:ext cx="365760" cy="146304"/>
-          </a:xfrm>
-          <a:prstGeom prst="rect">
-            <a:avLst/>
-          </a:prstGeom>
-          <a:noFill/>
-          <a:ln/>
-        </p:spPr>
-        <p:txBody>
-          <a:bodyPr wrap="square" lIns="0" tIns="0" rIns="0" bIns="0" rtlCol="0" anchor="ctr"/>
-          <a:lstStyle/>
-          <a:p>
-            <a:pPr indent="0" marL="0">
-              <a:buNone/>
-            </a:pPr>
-            <a:r>
-              <a:rPr lang="en-US" sz="800" dirty="0">
-                <a:solidFill>
-                  <a:srgbClr val="8A4300"/>
-                </a:solidFill>
-                <a:latin typeface="LINE Seed Sans KR" pitchFamily="34" charset="0"/>
-                <a:ea typeface="LINE Seed Sans KR" pitchFamily="34" charset="-122"/>
-                <a:cs typeface="LINE Seed Sans KR" pitchFamily="34" charset="-120"/>
-              </a:rPr>
-              <a:t>UST</a:t>
-            </a:r>
-            <a:endParaRPr lang="en-US" sz="800" dirty="0"/>
-          </a:p>
-        </p:txBody>
-      </p:sp>
-      <p:sp>
-        <p:nvSpPr>
-          <p:cNvPr id="63" name="floor_projector_62"/>
-          <p:cNvSpPr/>
-          <p:nvPr/>
-        </p:nvSpPr>
-        <p:spPr>
-          <a:xfrm>
-            <a:off x="2903873" y="2599073"/>
-            <a:ext cx="292608" cy="109728"/>
-          </a:xfrm>
-          <a:prstGeom prst="roundRect">
-            <a:avLst>
-              <a:gd name="adj" fmla="val 16667"/>
-            </a:avLst>
-          </a:prstGeom>
-          <a:solidFill>
-            <a:srgbClr val="FF8000"/>
-          </a:solidFill>
-          <a:ln/>
-        </p:spPr>
-      </p:sp>
-      <p:sp>
-        <p:nvSpPr>
-          <p:cNvPr id="64" name="label_floor_projector_63"/>
+          <p:cNvPr id="62" name="label_floor_projector_61"/>
           <p:cNvSpPr txBox="1"/>
           <p:nvPr/>
         </p:nvSpPr>
@@ -2586,7 +2525,7 @@
       </p:sp>
       <p:sp>
         <p:nvSpPr>
-          <p:cNvPr id="65" name="floor_projector_64"/>
+          <p:cNvPr id="63" name="floor_projector_62"/>
           <p:cNvSpPr/>
           <p:nvPr/>
         </p:nvSpPr>
@@ -2608,7 +2547,7 @@
       </p:sp>
       <p:sp>
         <p:nvSpPr>
-          <p:cNvPr id="66" name="label_floor_projector_65"/>
+          <p:cNvPr id="64" name="label_floor_projector_63"/>
           <p:cNvSpPr txBox="1"/>
           <p:nvPr/>
         </p:nvSpPr>
@@ -2647,7 +2586,7 @@
       </p:sp>
       <p:sp>
         <p:nvSpPr>
-          <p:cNvPr id="67" name="ceiling_sensor_66"/>
+          <p:cNvPr id="65" name="ceiling_sensor_64"/>
           <p:cNvSpPr/>
           <p:nvPr/>
         </p:nvSpPr>
@@ -2667,7 +2606,7 @@
       </p:sp>
       <p:sp>
         <p:nvSpPr>
-          <p:cNvPr id="68" name="label_ceiling_sensor_67"/>
+          <p:cNvPr id="66" name="label_ceiling_sensor_65"/>
           <p:cNvSpPr txBox="1"/>
           <p:nvPr/>
         </p:nvSpPr>
@@ -2706,7 +2645,7 @@
       </p:sp>
       <p:sp>
         <p:nvSpPr>
-          <p:cNvPr id="69" name="ceiling_sensor_68"/>
+          <p:cNvPr id="67" name="ceiling_sensor_66"/>
           <p:cNvSpPr/>
           <p:nvPr/>
         </p:nvSpPr>
@@ -2726,7 +2665,7 @@
       </p:sp>
       <p:sp>
         <p:nvSpPr>
-          <p:cNvPr id="70" name="label_ceiling_sensor_69"/>
+          <p:cNvPr id="68" name="label_ceiling_sensor_67"/>
           <p:cNvSpPr txBox="1"/>
           <p:nvPr/>
         </p:nvSpPr>
@@ -2765,7 +2704,7 @@
       </p:sp>
       <p:sp>
         <p:nvSpPr>
-          <p:cNvPr id="71" name="ceiling_sensor_70"/>
+          <p:cNvPr id="69" name="ceiling_sensor_68"/>
           <p:cNvSpPr/>
           <p:nvPr/>
         </p:nvSpPr>
@@ -2785,7 +2724,7 @@
       </p:sp>
       <p:sp>
         <p:nvSpPr>
-          <p:cNvPr id="72" name="label_ceiling_sensor_71"/>
+          <p:cNvPr id="70" name="label_ceiling_sensor_69"/>
           <p:cNvSpPr txBox="1"/>
           <p:nvPr/>
         </p:nvSpPr>
@@ -2824,7 +2763,7 @@
       </p:sp>
       <p:sp>
         <p:nvSpPr>
-          <p:cNvPr id="73" name="ceiling_sensor_72"/>
+          <p:cNvPr id="71" name="ceiling_sensor_70"/>
           <p:cNvSpPr/>
           <p:nvPr/>
         </p:nvSpPr>
@@ -2844,7 +2783,7 @@
       </p:sp>
       <p:sp>
         <p:nvSpPr>
-          <p:cNvPr id="74" name="label_ceiling_sensor_73"/>
+          <p:cNvPr id="72" name="label_ceiling_sensor_71"/>
           <p:cNvSpPr txBox="1"/>
           <p:nvPr/>
         </p:nvSpPr>
@@ -2883,7 +2822,7 @@
       </p:sp>
       <p:sp>
         <p:nvSpPr>
-          <p:cNvPr id="75" name="label_zone1_74"/>
+          <p:cNvPr id="73" name="label_zone1_72"/>
           <p:cNvSpPr txBox="1"/>
           <p:nvPr/>
         </p:nvSpPr>
@@ -2939,7 +2878,7 @@
       </p:sp>
       <p:sp>
         <p:nvSpPr>
-          <p:cNvPr id="76" name="label_zone2_75"/>
+          <p:cNvPr id="74" name="label_zone2_73"/>
           <p:cNvSpPr txBox="1"/>
           <p:nvPr/>
         </p:nvSpPr>
@@ -2995,7 +2934,7 @@
       </p:sp>
       <p:sp>
         <p:nvSpPr>
-          <p:cNvPr id="77" name="label_entrance_76"/>
+          <p:cNvPr id="75" name="label_entrance_74"/>
           <p:cNvSpPr txBox="1"/>
           <p:nvPr/>
         </p:nvSpPr>
@@ -3034,7 +2973,7 @@
       </p:sp>
       <p:sp>
         <p:nvSpPr>
-          <p:cNvPr id="78" name="dim_77"/>
+          <p:cNvPr id="76" name="dim_75"/>
           <p:cNvSpPr/>
           <p:nvPr/>
         </p:nvSpPr>
@@ -3057,7 +2996,7 @@
       </p:sp>
       <p:sp>
         <p:nvSpPr>
-          <p:cNvPr id="79" name="dim_78"/>
+          <p:cNvPr id="77" name="dim_76"/>
           <p:cNvSpPr/>
           <p:nvPr/>
         </p:nvSpPr>
@@ -3080,7 +3019,7 @@
       </p:sp>
       <p:sp>
         <p:nvSpPr>
-          <p:cNvPr id="80" name="dim_79"/>
+          <p:cNvPr id="78" name="dim_77"/>
           <p:cNvSpPr/>
           <p:nvPr/>
         </p:nvSpPr>
@@ -3103,7 +3042,7 @@
       </p:sp>
       <p:sp>
         <p:nvSpPr>
-          <p:cNvPr id="81" name="dim_label_80"/>
+          <p:cNvPr id="79" name="dim_label_78"/>
           <p:cNvSpPr txBox="1"/>
           <p:nvPr/>
         </p:nvSpPr>
@@ -3142,7 +3081,7 @@
       </p:sp>
       <p:sp>
         <p:nvSpPr>
-          <p:cNvPr id="82" name="dim_81"/>
+          <p:cNvPr id="80" name="dim_79"/>
           <p:cNvSpPr/>
           <p:nvPr/>
         </p:nvSpPr>
@@ -3165,7 +3104,7 @@
       </p:sp>
       <p:sp>
         <p:nvSpPr>
-          <p:cNvPr id="83" name="dim_82"/>
+          <p:cNvPr id="81" name="dim_80"/>
           <p:cNvSpPr/>
           <p:nvPr/>
         </p:nvSpPr>
@@ -3188,7 +3127,7 @@
       </p:sp>
       <p:sp>
         <p:nvSpPr>
-          <p:cNvPr id="84" name="dim_83"/>
+          <p:cNvPr id="82" name="dim_81"/>
           <p:cNvSpPr/>
           <p:nvPr/>
         </p:nvSpPr>
@@ -3211,7 +3150,7 @@
       </p:sp>
       <p:sp>
         <p:nvSpPr>
-          <p:cNvPr id="85" name="dim_label_84"/>
+          <p:cNvPr id="83" name="dim_label_82"/>
           <p:cNvSpPr txBox="1"/>
           <p:nvPr/>
         </p:nvSpPr>
@@ -3250,7 +3189,7 @@
       </p:sp>
       <p:sp>
         <p:nvSpPr>
-          <p:cNvPr id="86" name="legend_title_85"/>
+          <p:cNvPr id="84" name="legend_title_83"/>
           <p:cNvSpPr txBox="1"/>
           <p:nvPr/>
         </p:nvSpPr>
@@ -3289,13 +3228,13 @@
       </p:sp>
       <p:sp>
         <p:nvSpPr>
-          <p:cNvPr id="87" name="legend_swatch_86"/>
-          <p:cNvSpPr/>
-          <p:nvPr/>
-        </p:nvSpPr>
-        <p:spPr>
-          <a:xfrm>
-            <a:off x="7223760" y="1600200"/>
+          <p:cNvPr id="85" name="legend_swatch_84"/>
+          <p:cNvSpPr/>
+          <p:nvPr/>
+        </p:nvSpPr>
+        <p:spPr>
+          <a:xfrm>
+            <a:off x="7223760" y="1545336"/>
             <a:ext cx="256032" cy="146304"/>
           </a:xfrm>
           <a:prstGeom prst="rect">
@@ -3309,13 +3248,13 @@
       </p:sp>
       <p:sp>
         <p:nvSpPr>
-          <p:cNvPr id="88" name="legend_label_87"/>
+          <p:cNvPr id="86" name="legend_label_85"/>
           <p:cNvSpPr txBox="1"/>
           <p:nvPr/>
         </p:nvSpPr>
         <p:spPr>
           <a:xfrm>
-            <a:off x="7589520" y="1572768"/>
+            <a:off x="7589520" y="1517904"/>
             <a:ext cx="4206240" cy="201168"/>
           </a:xfrm>
           <a:prstGeom prst="rect">
@@ -3348,13 +3287,13 @@
       </p:sp>
       <p:sp>
         <p:nvSpPr>
-          <p:cNvPr id="89" name="legend_swatch_88"/>
-          <p:cNvSpPr/>
-          <p:nvPr/>
-        </p:nvSpPr>
-        <p:spPr>
-          <a:xfrm>
-            <a:off x="7223760" y="1874520"/>
+          <p:cNvPr id="87" name="legend_swatch_86"/>
+          <p:cNvSpPr/>
+          <p:nvPr/>
+        </p:nvSpPr>
+        <p:spPr>
+          <a:xfrm>
+            <a:off x="7223760" y="1801368"/>
             <a:ext cx="256032" cy="146304"/>
           </a:xfrm>
           <a:prstGeom prst="rect">
@@ -3368,13 +3307,13 @@
       </p:sp>
       <p:sp>
         <p:nvSpPr>
-          <p:cNvPr id="90" name="legend_label_89"/>
+          <p:cNvPr id="88" name="legend_label_87"/>
           <p:cNvSpPr txBox="1"/>
           <p:nvPr/>
         </p:nvSpPr>
         <p:spPr>
           <a:xfrm>
-            <a:off x="7589520" y="1847088"/>
+            <a:off x="7589520" y="1773936"/>
             <a:ext cx="4206240" cy="201168"/>
           </a:xfrm>
           <a:prstGeom prst="rect">
@@ -3407,13 +3346,13 @@
       </p:sp>
       <p:sp>
         <p:nvSpPr>
-          <p:cNvPr id="91" name="legend_swatch_90"/>
-          <p:cNvSpPr/>
-          <p:nvPr/>
-        </p:nvSpPr>
-        <p:spPr>
-          <a:xfrm>
-            <a:off x="7223760" y="2148840"/>
+          <p:cNvPr id="89" name="legend_swatch_88"/>
+          <p:cNvSpPr/>
+          <p:nvPr/>
+        </p:nvSpPr>
+        <p:spPr>
+          <a:xfrm>
+            <a:off x="7223760" y="2057400"/>
             <a:ext cx="256032" cy="146304"/>
           </a:xfrm>
           <a:prstGeom prst="roundRect">
@@ -3429,13 +3368,13 @@
       </p:sp>
       <p:sp>
         <p:nvSpPr>
-          <p:cNvPr id="92" name="legend_label_91"/>
+          <p:cNvPr id="90" name="legend_label_89"/>
           <p:cNvSpPr txBox="1"/>
           <p:nvPr/>
         </p:nvSpPr>
         <p:spPr>
           <a:xfrm>
-            <a:off x="7589520" y="2121408"/>
+            <a:off x="7589520" y="2029968"/>
             <a:ext cx="4206240" cy="201168"/>
           </a:xfrm>
           <a:prstGeom prst="rect">
@@ -3468,13 +3407,13 @@
       </p:sp>
       <p:sp>
         <p:nvSpPr>
-          <p:cNvPr id="93" name="legend_swatch_92"/>
-          <p:cNvSpPr/>
-          <p:nvPr/>
-        </p:nvSpPr>
-        <p:spPr>
-          <a:xfrm>
-            <a:off x="7223760" y="2423160"/>
+          <p:cNvPr id="91" name="legend_swatch_90"/>
+          <p:cNvSpPr/>
+          <p:nvPr/>
+        </p:nvSpPr>
+        <p:spPr>
+          <a:xfrm>
+            <a:off x="7223760" y="2313432"/>
             <a:ext cx="256032" cy="146304"/>
           </a:xfrm>
           <a:prstGeom prst="roundRect">
@@ -3495,13 +3434,13 @@
       </p:sp>
       <p:sp>
         <p:nvSpPr>
-          <p:cNvPr id="94" name="legend_label_93"/>
+          <p:cNvPr id="92" name="legend_label_91"/>
           <p:cNvSpPr txBox="1"/>
           <p:nvPr/>
         </p:nvSpPr>
         <p:spPr>
           <a:xfrm>
-            <a:off x="7589520" y="2395728"/>
+            <a:off x="7589520" y="2286000"/>
             <a:ext cx="4206240" cy="201168"/>
           </a:xfrm>
           <a:prstGeom prst="rect">
@@ -3534,13 +3473,13 @@
       </p:sp>
       <p:sp>
         <p:nvSpPr>
-          <p:cNvPr id="95" name="legend_swatch_94"/>
-          <p:cNvSpPr/>
-          <p:nvPr/>
-        </p:nvSpPr>
-        <p:spPr>
-          <a:xfrm>
-            <a:off x="7223760" y="2770632"/>
+          <p:cNvPr id="93" name="legend_swatch_92"/>
+          <p:cNvSpPr/>
+          <p:nvPr/>
+        </p:nvSpPr>
+        <p:spPr>
+          <a:xfrm>
+            <a:off x="7223760" y="2642616"/>
             <a:ext cx="256032" cy="0"/>
           </a:xfrm>
           <a:prstGeom prst="line">
@@ -3557,13 +3496,13 @@
       </p:sp>
       <p:sp>
         <p:nvSpPr>
-          <p:cNvPr id="96" name="legend_label_95"/>
+          <p:cNvPr id="94" name="legend_label_93"/>
           <p:cNvSpPr txBox="1"/>
           <p:nvPr/>
         </p:nvSpPr>
         <p:spPr>
           <a:xfrm>
-            <a:off x="7589520" y="2670048"/>
+            <a:off x="7589520" y="2542032"/>
             <a:ext cx="4206240" cy="201168"/>
           </a:xfrm>
           <a:prstGeom prst="rect">
@@ -3596,13 +3535,13 @@
       </p:sp>
       <p:sp>
         <p:nvSpPr>
-          <p:cNvPr id="97" name="legend_swatch_96"/>
-          <p:cNvSpPr/>
-          <p:nvPr/>
-        </p:nvSpPr>
-        <p:spPr>
-          <a:xfrm>
-            <a:off x="7223760" y="2971800"/>
+          <p:cNvPr id="95" name="legend_swatch_94"/>
+          <p:cNvSpPr/>
+          <p:nvPr/>
+        </p:nvSpPr>
+        <p:spPr>
+          <a:xfrm>
+            <a:off x="7223760" y="2825496"/>
             <a:ext cx="256032" cy="146304"/>
           </a:xfrm>
           <a:prstGeom prst="rect">
@@ -3623,13 +3562,13 @@
       </p:sp>
       <p:sp>
         <p:nvSpPr>
-          <p:cNvPr id="98" name="legend_label_97"/>
+          <p:cNvPr id="96" name="legend_label_95"/>
           <p:cNvSpPr txBox="1"/>
           <p:nvPr/>
         </p:nvSpPr>
         <p:spPr>
           <a:xfrm>
-            <a:off x="7589520" y="2944368"/>
+            <a:off x="7589520" y="2798064"/>
             <a:ext cx="4206240" cy="201168"/>
           </a:xfrm>
           <a:prstGeom prst="rect">
@@ -3662,13 +3601,13 @@
       </p:sp>
       <p:sp>
         <p:nvSpPr>
-          <p:cNvPr id="99" name="legend_swatch_98"/>
-          <p:cNvSpPr/>
-          <p:nvPr/>
-        </p:nvSpPr>
-        <p:spPr>
-          <a:xfrm>
-            <a:off x="7223760" y="3246120"/>
+          <p:cNvPr id="97" name="legend_swatch_96"/>
+          <p:cNvSpPr/>
+          <p:nvPr/>
+        </p:nvSpPr>
+        <p:spPr>
+          <a:xfrm>
+            <a:off x="7223760" y="3081528"/>
             <a:ext cx="256032" cy="146304"/>
           </a:xfrm>
           <a:prstGeom prst="rect">
@@ -3682,13 +3621,13 @@
       </p:sp>
       <p:sp>
         <p:nvSpPr>
-          <p:cNvPr id="100" name="legend_label_99"/>
+          <p:cNvPr id="98" name="legend_label_97"/>
           <p:cNvSpPr txBox="1"/>
           <p:nvPr/>
         </p:nvSpPr>
         <p:spPr>
           <a:xfrm>
-            <a:off x="7589520" y="3218688"/>
+            <a:off x="7589520" y="3054096"/>
             <a:ext cx="4206240" cy="201168"/>
           </a:xfrm>
           <a:prstGeom prst="rect">
@@ -3713,7 +3652,7 @@
                 <a:ea typeface="LINE Seed Sans KR" pitchFamily="34" charset="-122"/>
                 <a:cs typeface="LINE Seed Sans KR" pitchFamily="34" charset="-120"/>
               </a:rPr>
-              <a:t>프로젝터 (UST ×2 · 바닥 PJ ×2)</a:t>
+              <a:t>프로젝터 (벽 ×1 · 바닥 ×2 — 공간 높이 4.8 m 이상 기준)</a:t>
             </a:r>
             <a:endParaRPr lang="en-US" sz="1050" dirty="0"/>
           </a:p>
@@ -3721,13 +3660,13 @@
       </p:sp>
       <p:sp>
         <p:nvSpPr>
-          <p:cNvPr id="101" name="legend_swatch_100"/>
-          <p:cNvSpPr/>
-          <p:nvPr/>
-        </p:nvSpPr>
-        <p:spPr>
-          <a:xfrm>
-            <a:off x="7223760" y="3520440"/>
+          <p:cNvPr id="99" name="legend_swatch_98"/>
+          <p:cNvSpPr/>
+          <p:nvPr/>
+        </p:nvSpPr>
+        <p:spPr>
+          <a:xfrm>
+            <a:off x="7223760" y="3337560"/>
             <a:ext cx="256032" cy="146304"/>
           </a:xfrm>
           <a:prstGeom prst="rect">
@@ -3743,13 +3682,13 @@
       </p:sp>
       <p:sp>
         <p:nvSpPr>
-          <p:cNvPr id="102" name="legend_label_101"/>
+          <p:cNvPr id="100" name="legend_label_99"/>
           <p:cNvSpPr txBox="1"/>
           <p:nvPr/>
         </p:nvSpPr>
         <p:spPr>
           <a:xfrm>
-            <a:off x="7589520" y="3493008"/>
+            <a:off x="7589520" y="3310128"/>
             <a:ext cx="4206240" cy="201168"/>
           </a:xfrm>
           <a:prstGeom prst="rect">
@@ -3782,13 +3721,13 @@
       </p:sp>
       <p:sp>
         <p:nvSpPr>
-          <p:cNvPr id="103" name="legend_swatch_102"/>
-          <p:cNvSpPr/>
-          <p:nvPr/>
-        </p:nvSpPr>
-        <p:spPr>
-          <a:xfrm>
-            <a:off x="7287768" y="3803904"/>
+          <p:cNvPr id="101" name="legend_swatch_100"/>
+          <p:cNvSpPr/>
+          <p:nvPr/>
+        </p:nvSpPr>
+        <p:spPr>
+          <a:xfrm>
+            <a:off x="7287768" y="3602736"/>
             <a:ext cx="128016" cy="128016"/>
           </a:xfrm>
           <a:prstGeom prst="ellipse">
@@ -3802,13 +3741,13 @@
       </p:sp>
       <p:sp>
         <p:nvSpPr>
-          <p:cNvPr id="104" name="legend_label_103"/>
+          <p:cNvPr id="102" name="legend_label_101"/>
           <p:cNvSpPr txBox="1"/>
           <p:nvPr/>
         </p:nvSpPr>
         <p:spPr>
           <a:xfrm>
-            <a:off x="7589520" y="3767328"/>
+            <a:off x="7589520" y="3566160"/>
             <a:ext cx="4206240" cy="201168"/>
           </a:xfrm>
           <a:prstGeom prst="rect">
@@ -3841,13 +3780,13 @@
       </p:sp>
       <p:sp>
         <p:nvSpPr>
-          <p:cNvPr id="105" name="legend_swatch_104"/>
-          <p:cNvSpPr/>
-          <p:nvPr/>
-        </p:nvSpPr>
-        <p:spPr>
-          <a:xfrm>
-            <a:off x="7223760" y="4142232"/>
+          <p:cNvPr id="103" name="legend_swatch_102"/>
+          <p:cNvSpPr/>
+          <p:nvPr/>
+        </p:nvSpPr>
+        <p:spPr>
+          <a:xfrm>
+            <a:off x="7223760" y="3922776"/>
             <a:ext cx="256032" cy="0"/>
           </a:xfrm>
           <a:prstGeom prst="line">
@@ -3864,13 +3803,13 @@
       </p:sp>
       <p:sp>
         <p:nvSpPr>
-          <p:cNvPr id="106" name="legend_label_105"/>
+          <p:cNvPr id="104" name="legend_label_103"/>
           <p:cNvSpPr txBox="1"/>
           <p:nvPr/>
         </p:nvSpPr>
         <p:spPr>
           <a:xfrm>
-            <a:off x="7589520" y="4041648"/>
+            <a:off x="7589520" y="3822192"/>
             <a:ext cx="4206240" cy="201168"/>
           </a:xfrm>
           <a:prstGeom prst="rect">
@@ -3903,13 +3842,13 @@
       </p:sp>
       <p:sp>
         <p:nvSpPr>
-          <p:cNvPr id="107" name="legend_swatch_106"/>
-          <p:cNvSpPr/>
-          <p:nvPr/>
-        </p:nvSpPr>
-        <p:spPr>
-          <a:xfrm>
-            <a:off x="7287768" y="4352544"/>
+          <p:cNvPr id="105" name="legend_swatch_104"/>
+          <p:cNvSpPr/>
+          <p:nvPr/>
+        </p:nvSpPr>
+        <p:spPr>
+          <a:xfrm>
+            <a:off x="7287768" y="4114800"/>
             <a:ext cx="128016" cy="128016"/>
           </a:xfrm>
           <a:prstGeom prst="ellipse">
@@ -3923,13 +3862,13 @@
       </p:sp>
       <p:sp>
         <p:nvSpPr>
-          <p:cNvPr id="108" name="legend_label_107"/>
+          <p:cNvPr id="106" name="legend_label_105"/>
           <p:cNvSpPr txBox="1"/>
           <p:nvPr/>
         </p:nvSpPr>
         <p:spPr>
           <a:xfrm>
-            <a:off x="7589520" y="4315968"/>
+            <a:off x="7589520" y="4078224"/>
             <a:ext cx="4206240" cy="201168"/>
           </a:xfrm>
           <a:prstGeom prst="rect">
@@ -3962,13 +3901,13 @@
       </p:sp>
       <p:sp>
         <p:nvSpPr>
-          <p:cNvPr id="109" name="notes_title_108"/>
+          <p:cNvPr id="107" name="notes_title_106"/>
           <p:cNvSpPr txBox="1"/>
           <p:nvPr/>
         </p:nvSpPr>
         <p:spPr>
           <a:xfrm>
-            <a:off x="7223760" y="4754880"/>
+            <a:off x="7223760" y="4526280"/>
             <a:ext cx="2743200" cy="274320"/>
           </a:xfrm>
           <a:prstGeom prst="rect">
@@ -4001,14 +3940,14 @@
       </p:sp>
       <p:sp>
         <p:nvSpPr>
-          <p:cNvPr id="110" name="notes_109"/>
+          <p:cNvPr id="108" name="notes_107"/>
           <p:cNvSpPr txBox="1"/>
           <p:nvPr/>
         </p:nvSpPr>
         <p:spPr>
           <a:xfrm>
-            <a:off x="7223760" y="5074920"/>
-            <a:ext cx="4480560" cy="1188720"/>
+            <a:off x="7223760" y="4846320"/>
+            <a:ext cx="4480560" cy="1645920"/>
           </a:xfrm>
           <a:prstGeom prst="rect">
             <a:avLst/>
@@ -4099,7 +4038,28 @@
                 <a:ea typeface="LINE Seed Sans KR" pitchFamily="34" charset="-122"/>
                 <a:cs typeface="LINE Seed Sans KR" pitchFamily="34" charset="-120"/>
               </a:rPr>
-              <a:t>천장고 미확인. 천장 센서 개수·위치는 센서 사양으로 확정</a:t>
+              <a:t>공간 높이 미확인. 바닥 PJ는 4.8 m 이상 2대 / 4.2–4.8 m 3대 / 3.8–4.2 m 4대 (사내 HW 가이드 기준)</a:t>
+            </a:r>
+            <a:endParaRPr lang="en-US" sz="1000" dirty="0"/>
+          </a:p>
+          <a:p>
+            <a:pPr marL="342900" indent="-342900">
+              <a:spcAft>
+                <a:spcPts val="400"/>
+              </a:spcAft>
+              <a:buSzPct val="100000"/>
+              <a:buChar char="•"/>
+            </a:pPr>
+            <a:r>
+              <a:rPr lang="en-US" sz="1000" dirty="0">
+                <a:solidFill>
+                  <a:srgbClr val="353A40"/>
+                </a:solidFill>
+                <a:latin typeface="LINE Seed Sans KR" pitchFamily="34" charset="0"/>
+                <a:ea typeface="LINE Seed Sans KR" pitchFamily="34" charset="-122"/>
+                <a:cs typeface="LINE Seed Sans KR" pitchFamily="34" charset="-120"/>
+              </a:rPr>
+              <a:t>점수·타이머는 벽 투사 화면 상단에 포함 (별도 디스플레이 없음)</a:t>
             </a:r>
             <a:endParaRPr lang="en-US" sz="1000" dirty="0"/>
           </a:p>
@@ -4139,7 +4099,7 @@
       </p:grpSpPr>
       <p:sp>
         <p:nvSpPr>
-          <p:cNvPr id="2" name="title_110"/>
+          <p:cNvPr id="2" name="title_108"/>
           <p:cNvSpPr txBox="1"/>
           <p:nvPr/>
         </p:nvSpPr>
@@ -4178,7 +4138,7 @@
       </p:sp>
       <p:sp>
         <p:nvSpPr>
-          <p:cNvPr id="3" name="subtitle_111"/>
+          <p:cNvPr id="3" name="subtitle_109"/>
           <p:cNvSpPr txBox="1"/>
           <p:nvPr/>
         </p:nvSpPr>
@@ -4209,7 +4169,7 @@
                 <a:ea typeface="LINE Seed Sans KR" pitchFamily="34" charset="-122"/>
                 <a:cs typeface="LINE Seed Sans KR" pitchFamily="34" charset="-120"/>
               </a:rPr>
-              <a:t>출발(왼쪽) → 타깃 벽(오른쪽) · D 6,300 mm · 천장고 3,500 mm 가정 · 개략도</a:t>
+              <a:t>출발(왼쪽) → 타깃 벽(오른쪽) · D 6,300 mm · 천장 높이 미정 · 개략도</a:t>
             </a:r>
             <a:endParaRPr lang="en-US" sz="1100" dirty="0"/>
           </a:p>
@@ -4217,7 +4177,7 @@
       </p:sp>
       <p:sp>
         <p:nvSpPr>
-          <p:cNvPr id="4" name="beam_floor_PJ2_112"/>
+          <p:cNvPr id="4" name="beam_floor_PJ2_110"/>
           <p:cNvSpPr/>
           <p:nvPr/>
         </p:nvSpPr>
@@ -4264,7 +4224,7 @@
       </p:sp>
       <p:sp>
         <p:nvSpPr>
-          <p:cNvPr id="5" name="beam_floor_PJ1_113"/>
+          <p:cNvPr id="5" name="beam_floor_PJ1_111"/>
           <p:cNvSpPr/>
           <p:nvPr/>
         </p:nvSpPr>
@@ -4311,14 +4271,14 @@
       </p:sp>
       <p:sp>
         <p:nvSpPr>
-          <p:cNvPr id="6" name="beam_UST_114"/>
+          <p:cNvPr id="6" name="beam_wall_projector_112"/>
           <p:cNvSpPr/>
           <p:nvPr/>
         </p:nvSpPr>
         <p:spPr>
           <a:xfrm>
             <a:off x="7722181" y="1614569"/>
-            <a:ext cx="690299" cy="3249168"/>
+            <a:ext cx="690299" cy="3963271"/>
           </a:xfrm>
           <a:custGeom>
             <a:avLst/>
@@ -4327,15 +4287,15 @@
             <a:cxnLst/>
             <a:rect l="l" t="t" r="r" b="b"/>
             <a:pathLst>
-              <a:path w="690299" h="3249168">
+              <a:path w="690299" h="3963271">
                 <a:moveTo>
                   <a:pt x="0" y="0"/>
                 </a:moveTo>
                 <a:lnTo>
-                  <a:pt x="690299" y="1701945"/>
+                  <a:pt x="690299" y="618889"/>
                 </a:lnTo>
                 <a:lnTo>
-                  <a:pt x="690299" y="3249168"/>
+                  <a:pt x="690299" y="3963271"/>
                 </a:lnTo>
                 <a:close/>
               </a:path>
@@ -4343,7 +4303,7 @@
           </a:custGeom>
           <a:solidFill>
             <a:srgbClr val="FF8000">
-              <a:alpha val="20000"/>
+              <a:alpha val="15000"/>
             </a:srgbClr>
           </a:solidFill>
           <a:ln w="6350">
@@ -4358,7 +4318,7 @@
       </p:sp>
       <p:sp>
         <p:nvSpPr>
-          <p:cNvPr id="7" name="floor_115"/>
+          <p:cNvPr id="7" name="floor_113"/>
           <p:cNvSpPr/>
           <p:nvPr/>
         </p:nvSpPr>
@@ -4381,7 +4341,7 @@
       </p:sp>
       <p:sp>
         <p:nvSpPr>
-          <p:cNvPr id="8" name="ceiling_116"/>
+          <p:cNvPr id="8" name="ceiling_114"/>
           <p:cNvSpPr/>
           <p:nvPr/>
         </p:nvSpPr>
@@ -4404,7 +4364,7 @@
       </p:sp>
       <p:sp>
         <p:nvSpPr>
-          <p:cNvPr id="9" name="wall_target_117"/>
+          <p:cNvPr id="9" name="wall_target_115"/>
           <p:cNvSpPr/>
           <p:nvPr/>
         </p:nvSpPr>
@@ -4427,7 +4387,7 @@
       </p:sp>
       <p:sp>
         <p:nvSpPr>
-          <p:cNvPr id="10" name="label_ceiling_118"/>
+          <p:cNvPr id="10" name="label_ceiling_116"/>
           <p:cNvSpPr txBox="1"/>
           <p:nvPr/>
         </p:nvSpPr>
@@ -4458,7 +4418,7 @@
                 <a:ea typeface="LINE Seed Sans KR" pitchFamily="34" charset="-122"/>
                 <a:cs typeface="LINE Seed Sans KR" pitchFamily="34" charset="-120"/>
               </a:rPr>
-              <a:t>천장 (가정 3,500)</a:t>
+              <a:t>천장 (높이 미정)</a:t>
             </a:r>
             <a:endParaRPr lang="en-US" sz="1000" dirty="0"/>
           </a:p>
@@ -4466,7 +4426,7 @@
       </p:sp>
       <p:sp>
         <p:nvSpPr>
-          <p:cNvPr id="11" name="label_start_119"/>
+          <p:cNvPr id="11" name="label_start_117"/>
           <p:cNvSpPr txBox="1"/>
           <p:nvPr/>
         </p:nvSpPr>
@@ -4505,7 +4465,7 @@
       </p:sp>
       <p:sp>
         <p:nvSpPr>
-          <p:cNvPr id="12" name="target_projection_area_120"/>
+          <p:cNvPr id="12" name="target_projection_area_118"/>
           <p:cNvSpPr/>
           <p:nvPr/>
         </p:nvSpPr>
@@ -4525,7 +4485,7 @@
       </p:sp>
       <p:sp>
         <p:nvSpPr>
-          <p:cNvPr id="13" name="score_LED_121"/>
+          <p:cNvPr id="13" name="score_timer_projected_119"/>
           <p:cNvSpPr/>
           <p:nvPr/>
         </p:nvSpPr>
@@ -4545,7 +4505,7 @@
       </p:sp>
       <p:sp>
         <p:nvSpPr>
-          <p:cNvPr id="14" name="UST_projector_122"/>
+          <p:cNvPr id="14" name="wall_projector_120"/>
           <p:cNvSpPr/>
           <p:nvPr/>
         </p:nvSpPr>
@@ -4567,7 +4527,7 @@
       </p:sp>
       <p:sp>
         <p:nvSpPr>
-          <p:cNvPr id="15" name="floor_projector_123"/>
+          <p:cNvPr id="15" name="floor_projector_121"/>
           <p:cNvSpPr/>
           <p:nvPr/>
         </p:nvSpPr>
@@ -4589,7 +4549,7 @@
       </p:sp>
       <p:sp>
         <p:nvSpPr>
-          <p:cNvPr id="16" name="label_floor_projector_124"/>
+          <p:cNvPr id="16" name="label_floor_projector_122"/>
           <p:cNvSpPr txBox="1"/>
           <p:nvPr/>
         </p:nvSpPr>
@@ -4628,7 +4588,7 @@
       </p:sp>
       <p:sp>
         <p:nvSpPr>
-          <p:cNvPr id="17" name="floor_projector_125"/>
+          <p:cNvPr id="17" name="floor_projector_123"/>
           <p:cNvSpPr/>
           <p:nvPr/>
         </p:nvSpPr>
@@ -4650,7 +4610,7 @@
       </p:sp>
       <p:sp>
         <p:nvSpPr>
-          <p:cNvPr id="18" name="label_floor_projector_126"/>
+          <p:cNvPr id="18" name="label_floor_projector_124"/>
           <p:cNvSpPr txBox="1"/>
           <p:nvPr/>
         </p:nvSpPr>
@@ -4689,7 +4649,7 @@
       </p:sp>
       <p:sp>
         <p:nvSpPr>
-          <p:cNvPr id="19" name="ceiling_sensor_127"/>
+          <p:cNvPr id="19" name="ceiling_sensor_125"/>
           <p:cNvSpPr/>
           <p:nvPr/>
         </p:nvSpPr>
@@ -4709,7 +4669,7 @@
       </p:sp>
       <p:sp>
         <p:nvSpPr>
-          <p:cNvPr id="20" name="ceiling_sensor_128"/>
+          <p:cNvPr id="20" name="ceiling_sensor_126"/>
           <p:cNvSpPr/>
           <p:nvPr/>
         </p:nvSpPr>
@@ -4729,7 +4689,7 @@
       </p:sp>
       <p:sp>
         <p:nvSpPr>
-          <p:cNvPr id="21" name="label_ceiling_sensor_129"/>
+          <p:cNvPr id="21" name="label_ceiling_sensor_127"/>
           <p:cNvSpPr txBox="1"/>
           <p:nvPr/>
         </p:nvSpPr>
@@ -4768,7 +4728,7 @@
       </p:sp>
       <p:sp>
         <p:nvSpPr>
-          <p:cNvPr id="22" name="wall_sensor_130"/>
+          <p:cNvPr id="22" name="wall_sensor_128"/>
           <p:cNvSpPr/>
           <p:nvPr/>
         </p:nvSpPr>
@@ -4788,7 +4748,7 @@
       </p:sp>
       <p:sp>
         <p:nvSpPr>
-          <p:cNvPr id="23" name="wall_sensor_scan_131"/>
+          <p:cNvPr id="23" name="wall_sensor_scan_129"/>
           <p:cNvSpPr/>
           <p:nvPr/>
         </p:nvSpPr>
@@ -4811,7 +4771,7 @@
       </p:sp>
       <p:sp>
         <p:nvSpPr>
-          <p:cNvPr id="24" name="monkey_bar_132"/>
+          <p:cNvPr id="24" name="monkey_bar_130"/>
           <p:cNvSpPr/>
           <p:nvPr/>
         </p:nvSpPr>
@@ -4834,7 +4794,7 @@
       </p:sp>
       <p:sp>
         <p:nvSpPr>
-          <p:cNvPr id="25" name="monkey_bar_rung_133"/>
+          <p:cNvPr id="25" name="monkey_bar_rung_131"/>
           <p:cNvSpPr/>
           <p:nvPr/>
         </p:nvSpPr>
@@ -4857,7 +4817,7 @@
       </p:sp>
       <p:sp>
         <p:nvSpPr>
-          <p:cNvPr id="26" name="monkey_bar_rung_134"/>
+          <p:cNvPr id="26" name="monkey_bar_rung_132"/>
           <p:cNvSpPr/>
           <p:nvPr/>
         </p:nvSpPr>
@@ -4880,7 +4840,7 @@
       </p:sp>
       <p:sp>
         <p:nvSpPr>
-          <p:cNvPr id="27" name="monkey_bar_rung_135"/>
+          <p:cNvPr id="27" name="monkey_bar_rung_133"/>
           <p:cNvSpPr/>
           <p:nvPr/>
         </p:nvSpPr>
@@ -4903,7 +4863,7 @@
       </p:sp>
       <p:sp>
         <p:nvSpPr>
-          <p:cNvPr id="28" name="monkey_bar_rung_136"/>
+          <p:cNvPr id="28" name="monkey_bar_rung_134"/>
           <p:cNvSpPr/>
           <p:nvPr/>
         </p:nvSpPr>
@@ -4926,7 +4886,7 @@
       </p:sp>
       <p:sp>
         <p:nvSpPr>
-          <p:cNvPr id="29" name="monkey_bar_rung_137"/>
+          <p:cNvPr id="29" name="monkey_bar_rung_135"/>
           <p:cNvSpPr/>
           <p:nvPr/>
         </p:nvSpPr>
@@ -4949,7 +4909,7 @@
       </p:sp>
       <p:sp>
         <p:nvSpPr>
-          <p:cNvPr id="30" name="monkey_bar_rung_138"/>
+          <p:cNvPr id="30" name="monkey_bar_rung_136"/>
           <p:cNvSpPr/>
           <p:nvPr/>
         </p:nvSpPr>
@@ -4972,7 +4932,7 @@
       </p:sp>
       <p:sp>
         <p:nvSpPr>
-          <p:cNvPr id="31" name="monkey_bar_rung_139"/>
+          <p:cNvPr id="31" name="monkey_bar_rung_137"/>
           <p:cNvSpPr/>
           <p:nvPr/>
         </p:nvSpPr>
@@ -4995,7 +4955,7 @@
       </p:sp>
       <p:sp>
         <p:nvSpPr>
-          <p:cNvPr id="32" name="monkey_bar_rung_140"/>
+          <p:cNvPr id="32" name="monkey_bar_rung_138"/>
           <p:cNvSpPr/>
           <p:nvPr/>
         </p:nvSpPr>
@@ -5018,7 +4978,7 @@
       </p:sp>
       <p:sp>
         <p:nvSpPr>
-          <p:cNvPr id="33" name="monkey_bar_rung_141"/>
+          <p:cNvPr id="33" name="monkey_bar_rung_139"/>
           <p:cNvSpPr/>
           <p:nvPr/>
         </p:nvSpPr>
@@ -5041,7 +5001,7 @@
       </p:sp>
       <p:sp>
         <p:nvSpPr>
-          <p:cNvPr id="34" name="label_monkey_bar_142"/>
+          <p:cNvPr id="34" name="label_monkey_bar_140"/>
           <p:cNvSpPr txBox="1"/>
           <p:nvPr/>
         </p:nvSpPr>
@@ -5080,7 +5040,7 @@
       </p:sp>
       <p:sp>
         <p:nvSpPr>
-          <p:cNvPr id="35" name="kid_arm_143"/>
+          <p:cNvPr id="35" name="kid_arm_141"/>
           <p:cNvSpPr/>
           <p:nvPr/>
         </p:nvSpPr>
@@ -5103,7 +5063,7 @@
       </p:sp>
       <p:sp>
         <p:nvSpPr>
-          <p:cNvPr id="36" name="kid_arm_144"/>
+          <p:cNvPr id="36" name="kid_arm_142"/>
           <p:cNvSpPr/>
           <p:nvPr/>
         </p:nvSpPr>
@@ -5126,7 +5086,7 @@
       </p:sp>
       <p:sp>
         <p:nvSpPr>
-          <p:cNvPr id="37" name="kid_head_145"/>
+          <p:cNvPr id="37" name="kid_head_143"/>
           <p:cNvSpPr/>
           <p:nvPr/>
         </p:nvSpPr>
@@ -5146,7 +5106,7 @@
       </p:sp>
       <p:sp>
         <p:nvSpPr>
-          <p:cNvPr id="38" name="kid_body_146"/>
+          <p:cNvPr id="38" name="kid_body_144"/>
           <p:cNvSpPr/>
           <p:nvPr/>
         </p:nvSpPr>
@@ -5168,7 +5128,7 @@
       </p:sp>
       <p:sp>
         <p:nvSpPr>
-          <p:cNvPr id="39" name="kid_leg_147"/>
+          <p:cNvPr id="39" name="kid_leg_145"/>
           <p:cNvSpPr/>
           <p:nvPr/>
         </p:nvSpPr>
@@ -5191,7 +5151,7 @@
       </p:sp>
       <p:sp>
         <p:nvSpPr>
-          <p:cNvPr id="40" name="kid_leg_148"/>
+          <p:cNvPr id="40" name="kid_leg_146"/>
           <p:cNvSpPr/>
           <p:nvPr/>
         </p:nvSpPr>
@@ -5214,7 +5174,7 @@
       </p:sp>
       <p:sp>
         <p:nvSpPr>
-          <p:cNvPr id="41" name="box_bar_start_149"/>
+          <p:cNvPr id="41" name="box_bar_start_147"/>
           <p:cNvSpPr/>
           <p:nvPr/>
         </p:nvSpPr>
@@ -5236,7 +5196,7 @@
       </p:sp>
       <p:sp>
         <p:nvSpPr>
-          <p:cNvPr id="42" name="box_bar_end_150"/>
+          <p:cNvPr id="42" name="box_bar_end_148"/>
           <p:cNvSpPr/>
           <p:nvPr/>
         </p:nvSpPr>
@@ -5258,7 +5218,7 @@
       </p:sp>
       <p:sp>
         <p:nvSpPr>
-          <p:cNvPr id="43" name="box_beside_bar_151"/>
+          <p:cNvPr id="43" name="box_beside_bar_149"/>
           <p:cNvSpPr/>
           <p:nvPr/>
         </p:nvSpPr>
@@ -5285,7 +5245,7 @@
       </p:sp>
       <p:sp>
         <p:nvSpPr>
-          <p:cNvPr id="44" name="box_beside_bar_152"/>
+          <p:cNvPr id="44" name="box_beside_bar_150"/>
           <p:cNvSpPr/>
           <p:nvPr/>
         </p:nvSpPr>
@@ -5312,7 +5272,7 @@
       </p:sp>
       <p:sp>
         <p:nvSpPr>
-          <p:cNvPr id="45" name="box_center_153"/>
+          <p:cNvPr id="45" name="box_center_151"/>
           <p:cNvSpPr/>
           <p:nvPr/>
         </p:nvSpPr>
@@ -5334,7 +5294,7 @@
       </p:sp>
       <p:sp>
         <p:nvSpPr>
-          <p:cNvPr id="46" name="label_box_154"/>
+          <p:cNvPr id="46" name="label_box_152"/>
           <p:cNvSpPr txBox="1"/>
           <p:nvPr/>
         </p:nvSpPr>
@@ -5373,7 +5333,7 @@
       </p:sp>
       <p:sp>
         <p:nvSpPr>
-          <p:cNvPr id="47" name="label_box_155"/>
+          <p:cNvPr id="47" name="label_box_153"/>
           <p:cNvSpPr txBox="1"/>
           <p:nvPr/>
         </p:nvSpPr>
@@ -5412,7 +5372,7 @@
       </p:sp>
       <p:sp>
         <p:nvSpPr>
-          <p:cNvPr id="48" name="label_UST_156"/>
+          <p:cNvPr id="48" name="label_wall_projector_154"/>
           <p:cNvSpPr txBox="1"/>
           <p:nvPr/>
         </p:nvSpPr>
@@ -5443,7 +5403,7 @@
                 <a:ea typeface="LINE Seed Sans KR" pitchFamily="34" charset="-122"/>
                 <a:cs typeface="LINE Seed Sans KR" pitchFamily="34" charset="-120"/>
               </a:rPr>
-              <a:t>UST 레이저</a:t>
+              <a:t>벽 PJ ×1</a:t>
             </a:r>
             <a:endParaRPr lang="en-US" sz="1000" dirty="0"/>
           </a:p>
@@ -5460,7 +5420,7 @@
                 <a:ea typeface="LINE Seed Sans KR" pitchFamily="34" charset="-122"/>
                 <a:cs typeface="LINE Seed Sans KR" pitchFamily="34" charset="-120"/>
               </a:rPr>
-              <a:t>벽에서 0.61–0.83 m</a:t>
+              <a:t>벽 상부 근접 설치</a:t>
             </a:r>
             <a:endParaRPr lang="en-US" sz="1000" dirty="0"/>
           </a:p>
@@ -5468,7 +5428,7 @@
       </p:sp>
       <p:sp>
         <p:nvSpPr>
-          <p:cNvPr id="49" name="label_score_LED_157"/>
+          <p:cNvPr id="49" name="label_score_timer_155"/>
           <p:cNvSpPr txBox="1"/>
           <p:nvPr/>
         </p:nvSpPr>
@@ -5499,7 +5459,7 @@
                 <a:ea typeface="LINE Seed Sans KR" pitchFamily="34" charset="-122"/>
                 <a:cs typeface="LINE Seed Sans KR" pitchFamily="34" charset="-120"/>
               </a:rPr>
-              <a:t>점수 LED</a:t>
+              <a:t>점수 · 타이머 (투사)</a:t>
             </a:r>
             <a:endParaRPr lang="en-US" sz="1000" dirty="0"/>
           </a:p>
@@ -5507,7 +5467,7 @@
       </p:sp>
       <p:sp>
         <p:nvSpPr>
-          <p:cNvPr id="50" name="label_wall_sensor_158"/>
+          <p:cNvPr id="50" name="label_wall_sensor_156"/>
           <p:cNvSpPr txBox="1"/>
           <p:nvPr/>
         </p:nvSpPr>
@@ -5563,7 +5523,7 @@
       </p:sp>
       <p:sp>
         <p:nvSpPr>
-          <p:cNvPr id="51" name="label_target_159"/>
+          <p:cNvPr id="51" name="label_target_157"/>
           <p:cNvSpPr txBox="1"/>
           <p:nvPr/>
         </p:nvSpPr>
@@ -5619,7 +5579,7 @@
       </p:sp>
       <p:sp>
         <p:nvSpPr>
-          <p:cNvPr id="52" name="dim_160"/>
+          <p:cNvPr id="52" name="dim_158"/>
           <p:cNvSpPr/>
           <p:nvPr/>
         </p:nvSpPr>
@@ -5642,7 +5602,7 @@
       </p:sp>
       <p:sp>
         <p:nvSpPr>
-          <p:cNvPr id="53" name="dim_161"/>
+          <p:cNvPr id="53" name="dim_159"/>
           <p:cNvSpPr/>
           <p:nvPr/>
         </p:nvSpPr>
@@ -5665,7 +5625,7 @@
       </p:sp>
       <p:sp>
         <p:nvSpPr>
-          <p:cNvPr id="54" name="dim_162"/>
+          <p:cNvPr id="54" name="dim_160"/>
           <p:cNvSpPr/>
           <p:nvPr/>
         </p:nvSpPr>
@@ -5688,7 +5648,7 @@
       </p:sp>
       <p:sp>
         <p:nvSpPr>
-          <p:cNvPr id="55" name="dim_label_163"/>
+          <p:cNvPr id="55" name="dim_label_161"/>
           <p:cNvSpPr txBox="1"/>
           <p:nvPr/>
         </p:nvSpPr>
@@ -5727,7 +5687,7 @@
       </p:sp>
       <p:sp>
         <p:nvSpPr>
-          <p:cNvPr id="56" name="zone_tick_164"/>
+          <p:cNvPr id="56" name="zone_tick_162"/>
           <p:cNvSpPr/>
           <p:nvPr/>
         </p:nvSpPr>
@@ -5750,7 +5710,7 @@
       </p:sp>
       <p:sp>
         <p:nvSpPr>
-          <p:cNvPr id="57" name="label_zone2_165"/>
+          <p:cNvPr id="57" name="label_zone2_163"/>
           <p:cNvSpPr txBox="1"/>
           <p:nvPr/>
         </p:nvSpPr>
@@ -5789,7 +5749,7 @@
       </p:sp>
       <p:sp>
         <p:nvSpPr>
-          <p:cNvPr id="58" name="label_zone1_166"/>
+          <p:cNvPr id="58" name="label_zone1_164"/>
           <p:cNvSpPr txBox="1"/>
           <p:nvPr/>
         </p:nvSpPr>
@@ -5828,7 +5788,7 @@
       </p:sp>
       <p:sp>
         <p:nvSpPr>
-          <p:cNvPr id="59" name="caption_167"/>
+          <p:cNvPr id="59" name="caption_165"/>
           <p:cNvSpPr txBox="1"/>
           <p:nvPr/>
         </p:nvSpPr>

</xml_diff>